<commit_message>
Add Aymane El Youssi, Malak Bartal and Sara Baalla to report and slides
</commit_message>
<xml_diff>
--- a/output/RNN_Presentation.pptx
+++ b/output/RNN_Presentation.pptx
@@ -2,21 +2,21 @@
 <file path=ppt/presentation.xml><?xml version="1.0" encoding="utf-8"?>
 <p:presentation xmlns:p="http://schemas.openxmlformats.org/presentationml/2006/main">
   <p:sldMasterIdLst>
-    <p:sldMasterId xmlns:r="http://schemas.openxmlformats.org/officeDocument/2006/relationships" id="2147483648" r:id="R6bdbae4893df49fc"/>
+    <p:sldMasterId xmlns:r="http://schemas.openxmlformats.org/officeDocument/2006/relationships" id="2147483648" r:id="R64af1d856aac4915"/>
   </p:sldMasterIdLst>
   <p:notesMasterIdLst>
-    <p:notesMasterId xmlns:r="http://schemas.openxmlformats.org/officeDocument/2006/relationships" r:id="R4e4a8884d23a4070"/>
+    <p:notesMasterId xmlns:r="http://schemas.openxmlformats.org/officeDocument/2006/relationships" r:id="R34957486a6f0473f"/>
   </p:notesMasterIdLst>
   <p:sldIdLst>
-    <p:sldId xmlns:r="http://schemas.openxmlformats.org/officeDocument/2006/relationships" id="256" r:id="Raa78ea94160e4562"/>
-    <p:sldId xmlns:r="http://schemas.openxmlformats.org/officeDocument/2006/relationships" id="257" r:id="R0ff8fcaeafce4d18"/>
-    <p:sldId xmlns:r="http://schemas.openxmlformats.org/officeDocument/2006/relationships" id="258" r:id="R5a8e1cef3d204019"/>
-    <p:sldId xmlns:r="http://schemas.openxmlformats.org/officeDocument/2006/relationships" id="259" r:id="R686bf4e2f3064201"/>
-    <p:sldId xmlns:r="http://schemas.openxmlformats.org/officeDocument/2006/relationships" id="260" r:id="R99dde1f4242c4aa0"/>
-    <p:sldId xmlns:r="http://schemas.openxmlformats.org/officeDocument/2006/relationships" id="261" r:id="R6fe9010620b84e1b"/>
-    <p:sldId xmlns:r="http://schemas.openxmlformats.org/officeDocument/2006/relationships" id="262" r:id="Rdcfbef5d3c694e9e"/>
-    <p:sldId xmlns:r="http://schemas.openxmlformats.org/officeDocument/2006/relationships" id="263" r:id="Rf939d212c371418a"/>
-    <p:sldId xmlns:r="http://schemas.openxmlformats.org/officeDocument/2006/relationships" id="264" r:id="R0c9ebf01ae3e4dc5"/>
+    <p:sldId xmlns:r="http://schemas.openxmlformats.org/officeDocument/2006/relationships" id="256" r:id="R0af66112da3e4d96"/>
+    <p:sldId xmlns:r="http://schemas.openxmlformats.org/officeDocument/2006/relationships" id="257" r:id="R76eea9a5c73b452a"/>
+    <p:sldId xmlns:r="http://schemas.openxmlformats.org/officeDocument/2006/relationships" id="258" r:id="R411606b7ffa44d67"/>
+    <p:sldId xmlns:r="http://schemas.openxmlformats.org/officeDocument/2006/relationships" id="259" r:id="R43c25270d1644a1a"/>
+    <p:sldId xmlns:r="http://schemas.openxmlformats.org/officeDocument/2006/relationships" id="260" r:id="Rcedeab1d254b402d"/>
+    <p:sldId xmlns:r="http://schemas.openxmlformats.org/officeDocument/2006/relationships" id="261" r:id="R2b566891e75144df"/>
+    <p:sldId xmlns:r="http://schemas.openxmlformats.org/officeDocument/2006/relationships" id="262" r:id="R3eaffcda08b84c56"/>
+    <p:sldId xmlns:r="http://schemas.openxmlformats.org/officeDocument/2006/relationships" id="263" r:id="R68cf0feaae0b42c0"/>
+    <p:sldId xmlns:r="http://schemas.openxmlformats.org/officeDocument/2006/relationships" id="264" r:id="R5f840c7375f147ad"/>
   </p:sldIdLst>
   <p:sldSz cx="12192000" cy="6858000"/>
   <p:notesSz cx="6858000" cy="9144000"/>
@@ -450,7 +450,7 @@
           <a:lstStyle xmlns:a="http://schemas.openxmlformats.org/drawingml/2006/main"/>
           <a:p xmlns:a="http://schemas.openxmlformats.org/drawingml/2006/main">
             <a:r>
-              <a:t>45 seconds. Introduce the classification task and the three architectures. Mention that other team members must be added before the defense.</a:t>
+              <a:t>45 seconds. Introduce the team, the classification task and the three architectures.</a:t>
             </a:r>
           </a:p>
           <a:p xmlns:a="http://schemas.openxmlformats.org/drawingml/2006/main">
@@ -1102,7 +1102,7 @@
           <p:cNvPr id="3" name="Title">
             <a:extLst xmlns:a="http://schemas.openxmlformats.org/drawingml/2006/main">
               <a:ext uri="{FF2B5EF4-FFF2-40B4-BE49-F238E27FC236}">
-                <a16:creationId xmlns:a16="http://schemas.microsoft.com/office/drawing/2014/main" id="{834809FA-7FF5-49C3-ABE4-F954877BF752}"/>
+                <a16:creationId xmlns:a16="http://schemas.microsoft.com/office/drawing/2014/main" id="{798A921B-43FA-4054-A98C-1F6C53DCBC83}"/>
               </a:ext>
             </a:extLst>
           </p:cNvPr>
@@ -1331,7 +1331,7 @@
           <p:cNvPr id="2" name="Subtitle">
             <a:extLst xmlns:a="http://schemas.openxmlformats.org/drawingml/2006/main">
               <a:ext uri="{FF2B5EF4-FFF2-40B4-BE49-F238E27FC236}">
-                <a16:creationId xmlns:a16="http://schemas.microsoft.com/office/drawing/2014/main" id="{FAFB8F31-9EE3-4326-9749-30232CC75D7A}"/>
+                <a16:creationId xmlns:a16="http://schemas.microsoft.com/office/drawing/2014/main" id="{02D9BCAB-39BF-4E4B-80CC-13909B661D7A}"/>
               </a:ext>
             </a:extLst>
           </p:cNvPr>
@@ -1577,7 +1577,7 @@
           <p:cNvPr id="2" name="Section title">
             <a:extLst xmlns:a="http://schemas.openxmlformats.org/drawingml/2006/main">
               <a:ext uri="{FF2B5EF4-FFF2-40B4-BE49-F238E27FC236}">
-                <a16:creationId xmlns:a16="http://schemas.microsoft.com/office/drawing/2014/main" id="{3599EF6E-36A3-4B40-8B95-393974CCC91D}"/>
+                <a16:creationId xmlns:a16="http://schemas.microsoft.com/office/drawing/2014/main" id="{4606296A-6FB1-4EAE-9666-53F450CCF204}"/>
               </a:ext>
             </a:extLst>
           </p:cNvPr>
@@ -1823,7 +1823,7 @@
           <p:cNvPr id="3" name="Title">
             <a:extLst xmlns:a="http://schemas.openxmlformats.org/drawingml/2006/main">
               <a:ext uri="{FF2B5EF4-FFF2-40B4-BE49-F238E27FC236}">
-                <a16:creationId xmlns:a16="http://schemas.microsoft.com/office/drawing/2014/main" id="{8F555251-6557-46E9-952B-86F42BB30576}"/>
+                <a16:creationId xmlns:a16="http://schemas.microsoft.com/office/drawing/2014/main" id="{8E29D006-5DC2-4836-9596-FB123F9D084C}"/>
               </a:ext>
             </a:extLst>
           </p:cNvPr>
@@ -2052,7 +2052,7 @@
           <p:cNvPr id="2" name="Body">
             <a:extLst xmlns:a="http://schemas.openxmlformats.org/drawingml/2006/main">
               <a:ext uri="{FF2B5EF4-FFF2-40B4-BE49-F238E27FC236}">
-                <a16:creationId xmlns:a16="http://schemas.microsoft.com/office/drawing/2014/main" id="{31B527FE-F932-45A9-BBAC-4F8D661635FF}"/>
+                <a16:creationId xmlns:a16="http://schemas.microsoft.com/office/drawing/2014/main" id="{1FBC55C5-6FDE-43DC-B089-1F868905987F}"/>
               </a:ext>
             </a:extLst>
           </p:cNvPr>
@@ -2298,7 +2298,7 @@
           <p:cNvPr id="4" name="Title">
             <a:extLst xmlns:a="http://schemas.openxmlformats.org/drawingml/2006/main">
               <a:ext uri="{FF2B5EF4-FFF2-40B4-BE49-F238E27FC236}">
-                <a16:creationId xmlns:a16="http://schemas.microsoft.com/office/drawing/2014/main" id="{644F2F62-0859-4889-BE4E-1559C686DFDA}"/>
+                <a16:creationId xmlns:a16="http://schemas.microsoft.com/office/drawing/2014/main" id="{AA1442C1-4C91-4743-BD37-49A2BBF40DF8}"/>
               </a:ext>
             </a:extLst>
           </p:cNvPr>
@@ -2527,7 +2527,7 @@
           <p:cNvPr id="2" name="Left column">
             <a:extLst xmlns:a="http://schemas.openxmlformats.org/drawingml/2006/main">
               <a:ext uri="{FF2B5EF4-FFF2-40B4-BE49-F238E27FC236}">
-                <a16:creationId xmlns:a16="http://schemas.microsoft.com/office/drawing/2014/main" id="{65E62E7A-4A5B-4A8D-9CA8-C0D859A7CA57}"/>
+                <a16:creationId xmlns:a16="http://schemas.microsoft.com/office/drawing/2014/main" id="{75B19006-C81D-4BEA-B9C4-41F30DDA7091}"/>
               </a:ext>
             </a:extLst>
           </p:cNvPr>
@@ -2756,7 +2756,7 @@
           <p:cNvPr id="3" name="Right column">
             <a:extLst xmlns:a="http://schemas.openxmlformats.org/drawingml/2006/main">
               <a:ext uri="{FF2B5EF4-FFF2-40B4-BE49-F238E27FC236}">
-                <a16:creationId xmlns:a16="http://schemas.microsoft.com/office/drawing/2014/main" id="{D2070FA0-38D9-4C24-A523-1843CD018DEE}"/>
+                <a16:creationId xmlns:a16="http://schemas.microsoft.com/office/drawing/2014/main" id="{F1D7B1C8-15D3-4A21-ABF0-0D748F54881A}"/>
               </a:ext>
             </a:extLst>
           </p:cNvPr>
@@ -3002,7 +3002,7 @@
           <p:cNvPr id="3" name="Title">
             <a:extLst xmlns:a="http://schemas.openxmlformats.org/drawingml/2006/main">
               <a:ext uri="{FF2B5EF4-FFF2-40B4-BE49-F238E27FC236}">
-                <a16:creationId xmlns:a16="http://schemas.microsoft.com/office/drawing/2014/main" id="{6ABFF353-1E89-49F0-B4D8-2C96E3360147}"/>
+                <a16:creationId xmlns:a16="http://schemas.microsoft.com/office/drawing/2014/main" id="{4384982E-BF46-4B93-896F-B69F7B966E3A}"/>
               </a:ext>
             </a:extLst>
           </p:cNvPr>
@@ -3231,7 +3231,7 @@
           <p:cNvPr id="2" name="Left column">
             <a:extLst xmlns:a="http://schemas.openxmlformats.org/drawingml/2006/main">
               <a:ext uri="{FF2B5EF4-FFF2-40B4-BE49-F238E27FC236}">
-                <a16:creationId xmlns:a16="http://schemas.microsoft.com/office/drawing/2014/main" id="{DEAFF7D9-11DF-4856-8ED0-7240ED9814E6}"/>
+                <a16:creationId xmlns:a16="http://schemas.microsoft.com/office/drawing/2014/main" id="{22F31998-B3B4-4CB8-86AB-9C8BB8D354D5}"/>
               </a:ext>
             </a:extLst>
           </p:cNvPr>
@@ -3498,12 +3498,12 @@
   </p:cSld>
   <p:clrMap bg1="lt1" tx1="dk1" bg2="lt2" tx2="dk2" accent1="accent1" accent2="accent2" accent3="accent3" accent4="accent4" accent5="accent5" accent6="accent6" hlink="hlink" folHlink="folHlink"/>
   <p:sldLayoutIdLst>
-    <p:sldLayoutId xmlns:r="http://schemas.openxmlformats.org/officeDocument/2006/relationships" id="2147483649" r:id="R2984576fd0df4af2"/>
-    <p:sldLayoutId xmlns:r="http://schemas.openxmlformats.org/officeDocument/2006/relationships" id="2147483650" r:id="Rb7e85a728f4d4be6"/>
-    <p:sldLayoutId xmlns:r="http://schemas.openxmlformats.org/officeDocument/2006/relationships" id="2147483651" r:id="R1bb3617fa5624645"/>
-    <p:sldLayoutId xmlns:r="http://schemas.openxmlformats.org/officeDocument/2006/relationships" id="2147483652" r:id="R52ef8084db674626"/>
-    <p:sldLayoutId xmlns:r="http://schemas.openxmlformats.org/officeDocument/2006/relationships" id="2147483653" r:id="Rece73baab6d34cc6"/>
-    <p:sldLayoutId xmlns:r="http://schemas.openxmlformats.org/officeDocument/2006/relationships" id="2147483654" r:id="R1cfded44a6fd4fa5"/>
+    <p:sldLayoutId xmlns:r="http://schemas.openxmlformats.org/officeDocument/2006/relationships" id="2147483649" r:id="Ra530925ae07c452d"/>
+    <p:sldLayoutId xmlns:r="http://schemas.openxmlformats.org/officeDocument/2006/relationships" id="2147483650" r:id="R5895a126704e472a"/>
+    <p:sldLayoutId xmlns:r="http://schemas.openxmlformats.org/officeDocument/2006/relationships" id="2147483651" r:id="Ra4a5e256309c4b0f"/>
+    <p:sldLayoutId xmlns:r="http://schemas.openxmlformats.org/officeDocument/2006/relationships" id="2147483652" r:id="R89ccf1f672ab40ca"/>
+    <p:sldLayoutId xmlns:r="http://schemas.openxmlformats.org/officeDocument/2006/relationships" id="2147483653" r:id="R02780f8f3f83443d"/>
+    <p:sldLayoutId xmlns:r="http://schemas.openxmlformats.org/officeDocument/2006/relationships" id="2147483654" r:id="R9f485754fa134e60"/>
   </p:sldLayoutIdLst>
   <p:txStyles>
     <p:titleStyle>
@@ -4796,10 +4796,10 @@
       </p:grpSpPr>
       <p:sp>
         <p:nvSpPr>
-          <p:cNvPr id="5" name="">
+          <p:cNvPr id="6" name="">
             <a:extLst xmlns:a="http://schemas.openxmlformats.org/drawingml/2006/main">
               <a:ext uri="{FF2B5EF4-FFF2-40B4-BE49-F238E27FC236}">
-                <a16:creationId xmlns:a16="http://schemas.microsoft.com/office/drawing/2014/main" id="{87123B4E-FB00-4142-8369-206EEC37A44F}"/>
+                <a16:creationId xmlns:a16="http://schemas.microsoft.com/office/drawing/2014/main" id="{9B724DD2-7104-46F6-96CC-FE0DA619C0F1}"/>
               </a:ext>
             </a:extLst>
           </p:cNvPr>
@@ -4978,7 +4978,7 @@
           <p:cNvPr id="2" name="">
             <a:extLst xmlns:a="http://schemas.openxmlformats.org/drawingml/2006/main">
               <a:ext uri="{FF2B5EF4-FFF2-40B4-BE49-F238E27FC236}">
-                <a16:creationId xmlns:a16="http://schemas.microsoft.com/office/drawing/2014/main" id="{A3741E32-A947-44D9-8C95-DAF5C90BC435}"/>
+                <a16:creationId xmlns:a16="http://schemas.microsoft.com/office/drawing/2014/main" id="{2EC36BF1-B0CB-495E-B6E7-5EF4A4409686}"/>
               </a:ext>
             </a:extLst>
           </p:cNvPr>
@@ -5134,7 +5134,7 @@
           <p:cNvPr id="3" name="">
             <a:extLst xmlns:a="http://schemas.openxmlformats.org/drawingml/2006/main">
               <a:ext uri="{FF2B5EF4-FFF2-40B4-BE49-F238E27FC236}">
-                <a16:creationId xmlns:a16="http://schemas.microsoft.com/office/drawing/2014/main" id="{AD2E3BA1-AE96-4C54-B4BA-7F154D25DDE9}"/>
+                <a16:creationId xmlns:a16="http://schemas.microsoft.com/office/drawing/2014/main" id="{739B14E1-CACA-44E5-BF85-2E31572624E2}"/>
               </a:ext>
             </a:extLst>
           </p:cNvPr>
@@ -5145,8 +5145,8 @@
         </p:nvSpPr>
         <p:spPr>
           <a:xfrm xmlns:a="http://schemas.openxmlformats.org/drawingml/2006/main">
-            <a:off x="666750" y="4000500"/>
-            <a:ext cx="8572500" cy="1143000"/>
+            <a:off x="666750" y="3714750"/>
+            <a:ext cx="8096250" cy="1571625"/>
           </a:xfrm>
           <a:prstGeom xmlns:a="http://schemas.openxmlformats.org/drawingml/2006/main" prst="rect">
             <a:avLst/>
@@ -5160,7 +5160,7 @@
           <a:bodyPr xmlns:a="http://schemas.openxmlformats.org/drawingml/2006/main"/>
           <a:lstStyle xmlns:a="http://schemas.openxmlformats.org/drawingml/2006/main">
             <a:defPPr>
-              <a:defRPr sz="2100" b="0">
+              <a:defRPr sz="2025" b="0">
                 <a:solidFill>
                   <a:srgbClr val="23394D"/>
                 </a:solidFill>
@@ -5170,7 +5170,7 @@
               </a:defRPr>
             </a:defPPr>
             <a:lvl1pPr>
-              <a:defRPr sz="2100" b="0">
+              <a:defRPr sz="2025" b="0">
                 <a:solidFill>
                   <a:srgbClr val="23394D"/>
                 </a:solidFill>
@@ -5180,7 +5180,7 @@
               </a:defRPr>
             </a:lvl1pPr>
             <a:lvl2pPr>
-              <a:defRPr sz="2100" b="0">
+              <a:defRPr sz="2025" b="0">
                 <a:solidFill>
                   <a:srgbClr val="23394D"/>
                 </a:solidFill>
@@ -5190,7 +5190,7 @@
               </a:defRPr>
             </a:lvl2pPr>
             <a:lvl3pPr>
-              <a:defRPr sz="2100" b="0">
+              <a:defRPr sz="2025" b="0">
                 <a:solidFill>
                   <a:srgbClr val="23394D"/>
                 </a:solidFill>
@@ -5200,7 +5200,7 @@
               </a:defRPr>
             </a:lvl3pPr>
             <a:lvl4pPr>
-              <a:defRPr sz="2100" b="0">
+              <a:defRPr sz="2025" b="0">
                 <a:solidFill>
                   <a:srgbClr val="23394D"/>
                 </a:solidFill>
@@ -5210,7 +5210,7 @@
               </a:defRPr>
             </a:lvl4pPr>
             <a:lvl5pPr>
-              <a:defRPr sz="2100" b="0">
+              <a:defRPr sz="2025" b="0">
                 <a:solidFill>
                   <a:srgbClr val="23394D"/>
                 </a:solidFill>
@@ -5220,7 +5220,7 @@
               </a:defRPr>
             </a:lvl5pPr>
             <a:lvl6pPr>
-              <a:defRPr sz="2100" b="0">
+              <a:defRPr sz="2025" b="0">
                 <a:solidFill>
                   <a:srgbClr val="23394D"/>
                 </a:solidFill>
@@ -5230,7 +5230,7 @@
               </a:defRPr>
             </a:lvl6pPr>
             <a:lvl7pPr>
-              <a:defRPr sz="2100" b="0">
+              <a:defRPr sz="2025" b="0">
                 <a:solidFill>
                   <a:srgbClr val="23394D"/>
                 </a:solidFill>
@@ -5240,7 +5240,7 @@
               </a:defRPr>
             </a:lvl7pPr>
             <a:lvl8pPr>
-              <a:defRPr sz="2100" b="0">
+              <a:defRPr sz="2025" b="0">
                 <a:solidFill>
                   <a:srgbClr val="23394D"/>
                 </a:solidFill>
@@ -5250,7 +5250,7 @@
               </a:defRPr>
             </a:lvl8pPr>
             <a:lvl9pPr>
-              <a:defRPr sz="2100" b="0">
+              <a:defRPr sz="2025" b="0">
                 <a:solidFill>
                   <a:srgbClr val="23394D"/>
                 </a:solidFill>
@@ -5262,7 +5262,7 @@
           </a:lstStyle>
           <a:p xmlns:a="http://schemas.openxmlformats.org/drawingml/2006/main">
             <a:pPr>
-              <a:defRPr sz="2100" b="0">
+              <a:defRPr sz="2025" b="0">
                 <a:solidFill>
                   <a:srgbClr val="23394D"/>
                 </a:solidFill>
@@ -5272,7 +5272,7 @@
               </a:defRPr>
             </a:pPr>
             <a:r>
-              <a:rPr sz="2100" b="0">
+              <a:rPr sz="2025" b="0">
                 <a:solidFill>
                   <a:srgbClr val="23394D"/>
                 </a:solidFill>
@@ -5285,7 +5285,7 @@
           </a:p>
           <a:p xmlns:a="http://schemas.openxmlformats.org/drawingml/2006/main">
             <a:pPr>
-              <a:defRPr sz="2100" b="0">
+              <a:defRPr sz="2025" b="0">
                 <a:solidFill>
                   <a:srgbClr val="23394D"/>
                 </a:solidFill>
@@ -5295,7 +5295,209 @@
               </a:defRPr>
             </a:pPr>
             <a:r>
-              <a:rPr sz="2100" b="0">
+              <a:rPr sz="2025" b="0">
+                <a:solidFill>
+                  <a:srgbClr val="23394D"/>
+                </a:solidFill>
+                <a:latin typeface="Arial"/>
+                <a:ea typeface="Arial"/>
+                <a:cs typeface="Arial"/>
+              </a:rPr>
+              <a:t>Aymane El Youssi</a:t>
+            </a:r>
+          </a:p>
+          <a:p xmlns:a="http://schemas.openxmlformats.org/drawingml/2006/main">
+            <a:pPr>
+              <a:defRPr sz="2025" b="0">
+                <a:solidFill>
+                  <a:srgbClr val="23394D"/>
+                </a:solidFill>
+                <a:latin typeface="Arial"/>
+                <a:ea typeface="Arial"/>
+                <a:cs typeface="Arial"/>
+              </a:defRPr>
+            </a:pPr>
+            <a:r>
+              <a:rPr sz="2025" b="0">
+                <a:solidFill>
+                  <a:srgbClr val="23394D"/>
+                </a:solidFill>
+                <a:latin typeface="Arial"/>
+                <a:ea typeface="Arial"/>
+                <a:cs typeface="Arial"/>
+              </a:rPr>
+              <a:t>Malak Bartal</a:t>
+            </a:r>
+          </a:p>
+          <a:p xmlns:a="http://schemas.openxmlformats.org/drawingml/2006/main">
+            <a:pPr>
+              <a:defRPr sz="2025" b="0">
+                <a:solidFill>
+                  <a:srgbClr val="23394D"/>
+                </a:solidFill>
+                <a:latin typeface="Arial"/>
+                <a:ea typeface="Arial"/>
+                <a:cs typeface="Arial"/>
+              </a:defRPr>
+            </a:pPr>
+            <a:r>
+              <a:rPr sz="2025" b="0">
+                <a:solidFill>
+                  <a:srgbClr val="23394D"/>
+                </a:solidFill>
+                <a:latin typeface="Arial"/>
+                <a:ea typeface="Arial"/>
+                <a:cs typeface="Arial"/>
+              </a:rPr>
+              <a:t>Sara Baalla</a:t>
+            </a:r>
+          </a:p>
+        </p:txBody>
+      </p:sp>
+      <p:sp>
+        <p:nvSpPr>
+          <p:cNvPr id="4" name="">
+            <a:extLst xmlns:a="http://schemas.openxmlformats.org/drawingml/2006/main">
+              <a:ext uri="{FF2B5EF4-FFF2-40B4-BE49-F238E27FC236}">
+                <a16:creationId xmlns:a16="http://schemas.microsoft.com/office/drawing/2014/main" id="{A35C2325-9423-4E8B-8A67-DC8479A72C7F}"/>
+              </a:ext>
+            </a:extLst>
+          </p:cNvPr>
+          <p:cNvSpPr>
+            <a:spLocks xmlns:a="http://schemas.openxmlformats.org/drawingml/2006/main" noGrp="1"/>
+          </p:cNvSpPr>
+          <p:nvPr/>
+        </p:nvSpPr>
+        <p:spPr>
+          <a:xfrm xmlns:a="http://schemas.openxmlformats.org/drawingml/2006/main">
+            <a:off x="666750" y="5476875"/>
+            <a:ext cx="8572500" cy="523875"/>
+          </a:xfrm>
+          <a:prstGeom xmlns:a="http://schemas.openxmlformats.org/drawingml/2006/main" prst="rect">
+            <a:avLst/>
+          </a:prstGeom>
+          <a:noFill xmlns:a="http://schemas.openxmlformats.org/drawingml/2006/main"/>
+          <a:ln xmlns:a="http://schemas.openxmlformats.org/drawingml/2006/main" w="0">
+            <a:noFill/>
+          </a:ln>
+        </p:spPr>
+        <p:txBody>
+          <a:bodyPr xmlns:a="http://schemas.openxmlformats.org/drawingml/2006/main"/>
+          <a:lstStyle xmlns:a="http://schemas.openxmlformats.org/drawingml/2006/main">
+            <a:defPPr>
+              <a:defRPr sz="1875" b="0">
+                <a:solidFill>
+                  <a:srgbClr val="23394D"/>
+                </a:solidFill>
+                <a:latin typeface="Arial"/>
+                <a:ea typeface="Arial"/>
+                <a:cs typeface="Arial"/>
+              </a:defRPr>
+            </a:defPPr>
+            <a:lvl1pPr>
+              <a:defRPr sz="1875" b="0">
+                <a:solidFill>
+                  <a:srgbClr val="23394D"/>
+                </a:solidFill>
+                <a:latin typeface="Arial"/>
+                <a:ea typeface="Arial"/>
+                <a:cs typeface="Arial"/>
+              </a:defRPr>
+            </a:lvl1pPr>
+            <a:lvl2pPr>
+              <a:defRPr sz="1875" b="0">
+                <a:solidFill>
+                  <a:srgbClr val="23394D"/>
+                </a:solidFill>
+                <a:latin typeface="Arial"/>
+                <a:ea typeface="Arial"/>
+                <a:cs typeface="Arial"/>
+              </a:defRPr>
+            </a:lvl2pPr>
+            <a:lvl3pPr>
+              <a:defRPr sz="1875" b="0">
+                <a:solidFill>
+                  <a:srgbClr val="23394D"/>
+                </a:solidFill>
+                <a:latin typeface="Arial"/>
+                <a:ea typeface="Arial"/>
+                <a:cs typeface="Arial"/>
+              </a:defRPr>
+            </a:lvl3pPr>
+            <a:lvl4pPr>
+              <a:defRPr sz="1875" b="0">
+                <a:solidFill>
+                  <a:srgbClr val="23394D"/>
+                </a:solidFill>
+                <a:latin typeface="Arial"/>
+                <a:ea typeface="Arial"/>
+                <a:cs typeface="Arial"/>
+              </a:defRPr>
+            </a:lvl4pPr>
+            <a:lvl5pPr>
+              <a:defRPr sz="1875" b="0">
+                <a:solidFill>
+                  <a:srgbClr val="23394D"/>
+                </a:solidFill>
+                <a:latin typeface="Arial"/>
+                <a:ea typeface="Arial"/>
+                <a:cs typeface="Arial"/>
+              </a:defRPr>
+            </a:lvl5pPr>
+            <a:lvl6pPr>
+              <a:defRPr sz="1875" b="0">
+                <a:solidFill>
+                  <a:srgbClr val="23394D"/>
+                </a:solidFill>
+                <a:latin typeface="Arial"/>
+                <a:ea typeface="Arial"/>
+                <a:cs typeface="Arial"/>
+              </a:defRPr>
+            </a:lvl6pPr>
+            <a:lvl7pPr>
+              <a:defRPr sz="1875" b="0">
+                <a:solidFill>
+                  <a:srgbClr val="23394D"/>
+                </a:solidFill>
+                <a:latin typeface="Arial"/>
+                <a:ea typeface="Arial"/>
+                <a:cs typeface="Arial"/>
+              </a:defRPr>
+            </a:lvl7pPr>
+            <a:lvl8pPr>
+              <a:defRPr sz="1875" b="0">
+                <a:solidFill>
+                  <a:srgbClr val="23394D"/>
+                </a:solidFill>
+                <a:latin typeface="Arial"/>
+                <a:ea typeface="Arial"/>
+                <a:cs typeface="Arial"/>
+              </a:defRPr>
+            </a:lvl8pPr>
+            <a:lvl9pPr>
+              <a:defRPr sz="1875" b="0">
+                <a:solidFill>
+                  <a:srgbClr val="23394D"/>
+                </a:solidFill>
+                <a:latin typeface="Arial"/>
+                <a:ea typeface="Arial"/>
+                <a:cs typeface="Arial"/>
+              </a:defRPr>
+            </a:lvl9pPr>
+          </a:lstStyle>
+          <a:p xmlns:a="http://schemas.openxmlformats.org/drawingml/2006/main">
+            <a:pPr>
+              <a:defRPr sz="1875" b="0">
+                <a:solidFill>
+                  <a:srgbClr val="23394D"/>
+                </a:solidFill>
+                <a:latin typeface="Arial"/>
+                <a:ea typeface="Arial"/>
+                <a:cs typeface="Arial"/>
+              </a:defRPr>
+            </a:pPr>
+            <a:r>
+              <a:rPr sz="1875" b="0">
                 <a:solidFill>
                   <a:srgbClr val="23394D"/>
                 </a:solidFill>
@@ -5310,10 +5512,10 @@
       </p:sp>
       <p:pic>
         <p:nvPicPr>
-          <p:cNvPr id="4" name="">
+          <p:cNvPr id="5" name="">
             <a:extLst xmlns:a="http://schemas.openxmlformats.org/drawingml/2006/main">
               <a:ext uri="{FF2B5EF4-FFF2-40B4-BE49-F238E27FC236}">
-                <a16:creationId xmlns:a16="http://schemas.microsoft.com/office/drawing/2014/main" id="{7DB67BDC-5961-4595-A9B1-FE88CC818416}"/>
+                <a16:creationId xmlns:a16="http://schemas.microsoft.com/office/drawing/2014/main" id="{42D2FF86-32C2-4E5C-91CA-CB809AA618D3}"/>
               </a:ext>
             </a:extLst>
           </p:cNvPr>
@@ -5323,7 +5525,7 @@
           <p:nvPr/>
         </p:nvPicPr>
         <p:blipFill>
-          <a:blip xmlns:r="http://schemas.openxmlformats.org/officeDocument/2006/relationships" xmlns:a="http://schemas.openxmlformats.org/drawingml/2006/main" r:embed="R71e29a7b84464fac"/>
+          <a:blip xmlns:r="http://schemas.openxmlformats.org/officeDocument/2006/relationships" xmlns:a="http://schemas.openxmlformats.org/drawingml/2006/main" r:embed="R7a9a2d29f3904872"/>
           <a:stretch xmlns:a="http://schemas.openxmlformats.org/drawingml/2006/main"/>
         </p:blipFill>
         <p:spPr>
@@ -5339,7 +5541,7 @@
     </p:spTree>
     <p:extLst>
       <p:ext uri="{BB962C8B-B14F-4D97-AF65-F5344CB8AC3E}">
-        <p14:creationId xmlns:p14="http://schemas.microsoft.com/office/powerpoint/2010/main" val="1920267628"/>
+        <p14:creationId xmlns:p14="http://schemas.microsoft.com/office/powerpoint/2010/main" val="1815055896"/>
       </p:ext>
     </p:extLst>
   </p:cSld>
@@ -5370,7 +5572,7 @@
           <p:cNvPr id="6" name="">
             <a:extLst xmlns:a="http://schemas.openxmlformats.org/drawingml/2006/main">
               <a:ext uri="{FF2B5EF4-FFF2-40B4-BE49-F238E27FC236}">
-                <a16:creationId xmlns:a16="http://schemas.microsoft.com/office/drawing/2014/main" id="{59526DBF-C554-430D-AB94-9977E498DC30}"/>
+                <a16:creationId xmlns:a16="http://schemas.microsoft.com/office/drawing/2014/main" id="{4991022B-B941-4FC4-95EA-56F33A77EF27}"/>
               </a:ext>
             </a:extLst>
           </p:cNvPr>
@@ -5526,7 +5728,7 @@
           <p:cNvPr id="2" name="">
             <a:extLst xmlns:a="http://schemas.openxmlformats.org/drawingml/2006/main">
               <a:ext uri="{FF2B5EF4-FFF2-40B4-BE49-F238E27FC236}">
-                <a16:creationId xmlns:a16="http://schemas.microsoft.com/office/drawing/2014/main" id="{C7D3A84B-6357-4F8C-8627-835ABC12009C}"/>
+                <a16:creationId xmlns:a16="http://schemas.microsoft.com/office/drawing/2014/main" id="{3B2886EE-727B-4E5E-BC92-CDB0FE8A9D8F}"/>
               </a:ext>
             </a:extLst>
           </p:cNvPr>
@@ -5682,7 +5884,7 @@
           <p:cNvPr id="3" name="">
             <a:extLst xmlns:a="http://schemas.openxmlformats.org/drawingml/2006/main">
               <a:ext uri="{FF2B5EF4-FFF2-40B4-BE49-F238E27FC236}">
-                <a16:creationId xmlns:a16="http://schemas.microsoft.com/office/drawing/2014/main" id="{8C842609-4855-47DB-8A9E-F93F3796ED8F}"/>
+                <a16:creationId xmlns:a16="http://schemas.microsoft.com/office/drawing/2014/main" id="{D3434AF8-EEB5-4EC5-B590-2698596108E2}"/>
               </a:ext>
             </a:extLst>
           </p:cNvPr>
@@ -5838,7 +6040,7 @@
           <p:cNvPr id="4" name="">
             <a:extLst xmlns:a="http://schemas.openxmlformats.org/drawingml/2006/main">
               <a:ext uri="{FF2B5EF4-FFF2-40B4-BE49-F238E27FC236}">
-                <a16:creationId xmlns:a16="http://schemas.microsoft.com/office/drawing/2014/main" id="{A8C8D5CB-C9EE-445F-8E4B-E53DC00E7C27}"/>
+                <a16:creationId xmlns:a16="http://schemas.microsoft.com/office/drawing/2014/main" id="{768B6F1C-C75D-4452-A066-662DD33373D0}"/>
               </a:ext>
             </a:extLst>
           </p:cNvPr>
@@ -5994,7 +6196,7 @@
           <p:cNvPr id="5" name="">
             <a:extLst xmlns:a="http://schemas.openxmlformats.org/drawingml/2006/main">
               <a:ext uri="{FF2B5EF4-FFF2-40B4-BE49-F238E27FC236}">
-                <a16:creationId xmlns:a16="http://schemas.microsoft.com/office/drawing/2014/main" id="{75BA27A9-F8B7-4B68-8663-FE4E1560DDF3}"/>
+                <a16:creationId xmlns:a16="http://schemas.microsoft.com/office/drawing/2014/main" id="{D7386A4E-C4DE-4B38-9AA5-A81F89991833}"/>
               </a:ext>
             </a:extLst>
           </p:cNvPr>
@@ -6148,7 +6350,7 @@
     </p:spTree>
     <p:extLst>
       <p:ext uri="{BB962C8B-B14F-4D97-AF65-F5344CB8AC3E}">
-        <p14:creationId xmlns:p14="http://schemas.microsoft.com/office/powerpoint/2010/main" val="586913293"/>
+        <p14:creationId xmlns:p14="http://schemas.microsoft.com/office/powerpoint/2010/main" val="162957639"/>
       </p:ext>
     </p:extLst>
   </p:cSld>
@@ -6179,7 +6381,7 @@
           <p:cNvPr id="5" name="">
             <a:extLst xmlns:a="http://schemas.openxmlformats.org/drawingml/2006/main">
               <a:ext uri="{FF2B5EF4-FFF2-40B4-BE49-F238E27FC236}">
-                <a16:creationId xmlns:a16="http://schemas.microsoft.com/office/drawing/2014/main" id="{C8B2B694-DF0A-47F3-9846-3635922FAA3C}"/>
+                <a16:creationId xmlns:a16="http://schemas.microsoft.com/office/drawing/2014/main" id="{019E591D-4017-4519-8138-80324132CDDE}"/>
               </a:ext>
             </a:extLst>
           </p:cNvPr>
@@ -6335,7 +6537,7 @@
           <p:cNvPr id="2" name="Chart">
             <a:extLst xmlns:a="http://schemas.openxmlformats.org/drawingml/2006/main">
               <a:ext uri="{FF2B5EF4-FFF2-40B4-BE49-F238E27FC236}">
-                <a16:creationId xmlns:a16="http://schemas.microsoft.com/office/drawing/2014/main" id="{D40F1513-A24B-4759-913F-7A2B9BCD3E35}"/>
+                <a16:creationId xmlns:a16="http://schemas.microsoft.com/office/drawing/2014/main" id="{4C0E9B35-2E81-413C-83DD-2DBB5A287F65}"/>
               </a:ext>
             </a:extLst>
           </p:cNvPr>
@@ -6348,7 +6550,7 @@
         </p:xfrm>
         <a:graphic xmlns:a="http://schemas.openxmlformats.org/drawingml/2006/main">
           <a:graphicData uri="http://schemas.openxmlformats.org/drawingml/2006/chart">
-            <c:chart xmlns:r="http://schemas.openxmlformats.org/officeDocument/2006/relationships" xmlns:c="http://schemas.openxmlformats.org/drawingml/2006/chart" r:id="Rc989a90b7f4b4f06"/>
+            <c:chart xmlns:r="http://schemas.openxmlformats.org/officeDocument/2006/relationships" xmlns:c="http://schemas.openxmlformats.org/drawingml/2006/chart" r:id="R0b468b24c0d34e83"/>
           </a:graphicData>
         </a:graphic>
       </p:graphicFrame>
@@ -6357,7 +6559,7 @@
           <p:cNvPr id="3" name="">
             <a:extLst xmlns:a="http://schemas.openxmlformats.org/drawingml/2006/main">
               <a:ext uri="{FF2B5EF4-FFF2-40B4-BE49-F238E27FC236}">
-                <a16:creationId xmlns:a16="http://schemas.microsoft.com/office/drawing/2014/main" id="{F6C3964C-B5BB-4926-915E-1946CDA08372}"/>
+                <a16:creationId xmlns:a16="http://schemas.microsoft.com/office/drawing/2014/main" id="{F85CFE41-8230-49E4-901B-DE1D4159675D}"/>
               </a:ext>
             </a:extLst>
           </p:cNvPr>
@@ -6559,7 +6761,7 @@
           <p:cNvPr id="4" name="">
             <a:extLst xmlns:a="http://schemas.openxmlformats.org/drawingml/2006/main">
               <a:ext uri="{FF2B5EF4-FFF2-40B4-BE49-F238E27FC236}">
-                <a16:creationId xmlns:a16="http://schemas.microsoft.com/office/drawing/2014/main" id="{2DB9126E-76BB-4CD5-AD7A-A97690DC6D6C}"/>
+                <a16:creationId xmlns:a16="http://schemas.microsoft.com/office/drawing/2014/main" id="{15F7C2BD-9653-452C-938C-DCBF2915C7EC}"/>
               </a:ext>
             </a:extLst>
           </p:cNvPr>
@@ -6736,7 +6938,7 @@
     </p:spTree>
     <p:extLst>
       <p:ext uri="{BB962C8B-B14F-4D97-AF65-F5344CB8AC3E}">
-        <p14:creationId xmlns:p14="http://schemas.microsoft.com/office/powerpoint/2010/main" val="1430191370"/>
+        <p14:creationId xmlns:p14="http://schemas.microsoft.com/office/powerpoint/2010/main" val="1994779686"/>
       </p:ext>
     </p:extLst>
   </p:cSld>
@@ -6767,7 +6969,7 @@
           <p:cNvPr id="6" name="">
             <a:extLst xmlns:a="http://schemas.openxmlformats.org/drawingml/2006/main">
               <a:ext uri="{FF2B5EF4-FFF2-40B4-BE49-F238E27FC236}">
-                <a16:creationId xmlns:a16="http://schemas.microsoft.com/office/drawing/2014/main" id="{CCB7C31A-3FC0-4767-A0FB-4FA333128E5C}"/>
+                <a16:creationId xmlns:a16="http://schemas.microsoft.com/office/drawing/2014/main" id="{82997154-37B2-4C67-9762-14CE7DBDB6D6}"/>
               </a:ext>
             </a:extLst>
           </p:cNvPr>
@@ -6923,7 +7125,7 @@
           <p:cNvPr id="2" name="">
             <a:extLst xmlns:a="http://schemas.openxmlformats.org/drawingml/2006/main">
               <a:ext uri="{FF2B5EF4-FFF2-40B4-BE49-F238E27FC236}">
-                <a16:creationId xmlns:a16="http://schemas.microsoft.com/office/drawing/2014/main" id="{820EA987-E0A3-4319-BF4E-CCC78C4D1715}"/>
+                <a16:creationId xmlns:a16="http://schemas.microsoft.com/office/drawing/2014/main" id="{A59A3B20-F20E-4EF4-BE89-83F6A1DAC1E2}"/>
               </a:ext>
             </a:extLst>
           </p:cNvPr>
@@ -7079,7 +7281,7 @@
           <p:cNvPr id="3" name="">
             <a:extLst xmlns:a="http://schemas.openxmlformats.org/drawingml/2006/main">
               <a:ext uri="{FF2B5EF4-FFF2-40B4-BE49-F238E27FC236}">
-                <a16:creationId xmlns:a16="http://schemas.microsoft.com/office/drawing/2014/main" id="{3880E9BD-F774-4489-88F6-D94E37930999}"/>
+                <a16:creationId xmlns:a16="http://schemas.microsoft.com/office/drawing/2014/main" id="{9F55A362-BBBD-4BB9-AA77-AADC88461BFF}"/>
               </a:ext>
             </a:extLst>
           </p:cNvPr>
@@ -7235,7 +7437,7 @@
           <p:cNvPr id="4" name="">
             <a:extLst xmlns:a="http://schemas.openxmlformats.org/drawingml/2006/main">
               <a:ext uri="{FF2B5EF4-FFF2-40B4-BE49-F238E27FC236}">
-                <a16:creationId xmlns:a16="http://schemas.microsoft.com/office/drawing/2014/main" id="{BCB1DA01-A41D-40FA-A893-10A79D22A937}"/>
+                <a16:creationId xmlns:a16="http://schemas.microsoft.com/office/drawing/2014/main" id="{324686B6-B289-4E7D-A582-C79034961765}"/>
               </a:ext>
             </a:extLst>
           </p:cNvPr>
@@ -7391,7 +7593,7 @@
           <p:cNvPr id="5" name="">
             <a:extLst xmlns:a="http://schemas.openxmlformats.org/drawingml/2006/main">
               <a:ext uri="{FF2B5EF4-FFF2-40B4-BE49-F238E27FC236}">
-                <a16:creationId xmlns:a16="http://schemas.microsoft.com/office/drawing/2014/main" id="{2A031C90-8561-4BA6-8BC4-84F0F874497B}"/>
+                <a16:creationId xmlns:a16="http://schemas.microsoft.com/office/drawing/2014/main" id="{3D3647B7-257A-4808-A92B-BF865BE9F85A}"/>
               </a:ext>
             </a:extLst>
           </p:cNvPr>
@@ -7545,7 +7747,7 @@
     </p:spTree>
     <p:extLst>
       <p:ext uri="{BB962C8B-B14F-4D97-AF65-F5344CB8AC3E}">
-        <p14:creationId xmlns:p14="http://schemas.microsoft.com/office/powerpoint/2010/main" val="837875084"/>
+        <p14:creationId xmlns:p14="http://schemas.microsoft.com/office/powerpoint/2010/main" val="1852580129"/>
       </p:ext>
     </p:extLst>
   </p:cSld>
@@ -7576,7 +7778,7 @@
           <p:cNvPr id="4" name="">
             <a:extLst xmlns:a="http://schemas.openxmlformats.org/drawingml/2006/main">
               <a:ext uri="{FF2B5EF4-FFF2-40B4-BE49-F238E27FC236}">
-                <a16:creationId xmlns:a16="http://schemas.microsoft.com/office/drawing/2014/main" id="{4026F4D0-D3D0-4108-BE66-930E4B1A2BE6}"/>
+                <a16:creationId xmlns:a16="http://schemas.microsoft.com/office/drawing/2014/main" id="{007AD37C-AF69-49A3-B8CE-9DAD18E120B8}"/>
               </a:ext>
             </a:extLst>
           </p:cNvPr>
@@ -7732,7 +7934,7 @@
           <p:cNvPr id="2" name="">
             <a:extLst xmlns:a="http://schemas.openxmlformats.org/drawingml/2006/main">
               <a:ext uri="{FF2B5EF4-FFF2-40B4-BE49-F238E27FC236}">
-                <a16:creationId xmlns:a16="http://schemas.microsoft.com/office/drawing/2014/main" id="{2BA8CCBF-4C40-4F47-8663-56580DA808A8}"/>
+                <a16:creationId xmlns:a16="http://schemas.microsoft.com/office/drawing/2014/main" id="{A40E9A81-3308-4B34-8829-4990D693F132}"/>
               </a:ext>
             </a:extLst>
           </p:cNvPr>
@@ -8057,7 +8259,7 @@
           <p:cNvPr id="3" name="">
             <a:extLst xmlns:a="http://schemas.openxmlformats.org/drawingml/2006/main">
               <a:ext uri="{FF2B5EF4-FFF2-40B4-BE49-F238E27FC236}">
-                <a16:creationId xmlns:a16="http://schemas.microsoft.com/office/drawing/2014/main" id="{966B798A-4F70-4E3B-A5A8-3FE9E904E5AF}"/>
+                <a16:creationId xmlns:a16="http://schemas.microsoft.com/office/drawing/2014/main" id="{9BF98B34-B8B0-4007-9CC4-CBFEE4D540BC}"/>
               </a:ext>
             </a:extLst>
           </p:cNvPr>
@@ -8211,7 +8413,7 @@
     </p:spTree>
     <p:extLst>
       <p:ext uri="{BB962C8B-B14F-4D97-AF65-F5344CB8AC3E}">
-        <p14:creationId xmlns:p14="http://schemas.microsoft.com/office/powerpoint/2010/main" val="1810541597"/>
+        <p14:creationId xmlns:p14="http://schemas.microsoft.com/office/powerpoint/2010/main" val="2016874944"/>
       </p:ext>
     </p:extLst>
   </p:cSld>
@@ -8242,7 +8444,7 @@
           <p:cNvPr id="4" name="">
             <a:extLst xmlns:a="http://schemas.openxmlformats.org/drawingml/2006/main">
               <a:ext uri="{FF2B5EF4-FFF2-40B4-BE49-F238E27FC236}">
-                <a16:creationId xmlns:a16="http://schemas.microsoft.com/office/drawing/2014/main" id="{D948F095-9BDF-43F3-9473-143B04FD8DFA}"/>
+                <a16:creationId xmlns:a16="http://schemas.microsoft.com/office/drawing/2014/main" id="{DF4CCE2C-38AE-41F5-9BE9-CBB80694CF70}"/>
               </a:ext>
             </a:extLst>
           </p:cNvPr>
@@ -8398,7 +8600,7 @@
           <p:cNvPr id="2" name="Chart">
             <a:extLst xmlns:a="http://schemas.openxmlformats.org/drawingml/2006/main">
               <a:ext uri="{FF2B5EF4-FFF2-40B4-BE49-F238E27FC236}">
-                <a16:creationId xmlns:a16="http://schemas.microsoft.com/office/drawing/2014/main" id="{6B94F27A-EC6A-4F05-A747-C4879C15C349}"/>
+                <a16:creationId xmlns:a16="http://schemas.microsoft.com/office/drawing/2014/main" id="{74D5F8B2-A802-4797-8AED-131645EB869F}"/>
               </a:ext>
             </a:extLst>
           </p:cNvPr>
@@ -8411,7 +8613,7 @@
         </p:xfrm>
         <a:graphic xmlns:a="http://schemas.openxmlformats.org/drawingml/2006/main">
           <a:graphicData uri="http://schemas.openxmlformats.org/drawingml/2006/chart">
-            <c:chart xmlns:r="http://schemas.openxmlformats.org/officeDocument/2006/relationships" xmlns:c="http://schemas.openxmlformats.org/drawingml/2006/chart" r:id="Rda3d5477a4334054"/>
+            <c:chart xmlns:r="http://schemas.openxmlformats.org/officeDocument/2006/relationships" xmlns:c="http://schemas.openxmlformats.org/drawingml/2006/chart" r:id="Rf5552a8820d048de"/>
           </a:graphicData>
         </a:graphic>
       </p:graphicFrame>
@@ -8420,7 +8622,7 @@
           <p:cNvPr id="3" name="">
             <a:extLst xmlns:a="http://schemas.openxmlformats.org/drawingml/2006/main">
               <a:ext uri="{FF2B5EF4-FFF2-40B4-BE49-F238E27FC236}">
-                <a16:creationId xmlns:a16="http://schemas.microsoft.com/office/drawing/2014/main" id="{A61A9540-5D50-4B2C-AA04-30A774CF506A}"/>
+                <a16:creationId xmlns:a16="http://schemas.microsoft.com/office/drawing/2014/main" id="{F61E7B66-449B-447B-A1AF-BB4FA95C56A4}"/>
               </a:ext>
             </a:extLst>
           </p:cNvPr>
@@ -8574,7 +8776,7 @@
     </p:spTree>
     <p:extLst>
       <p:ext uri="{BB962C8B-B14F-4D97-AF65-F5344CB8AC3E}">
-        <p14:creationId xmlns:p14="http://schemas.microsoft.com/office/powerpoint/2010/main" val="585954289"/>
+        <p14:creationId xmlns:p14="http://schemas.microsoft.com/office/powerpoint/2010/main" val="1186604705"/>
       </p:ext>
     </p:extLst>
   </p:cSld>
@@ -8605,7 +8807,7 @@
           <p:cNvPr id="4" name="">
             <a:extLst xmlns:a="http://schemas.openxmlformats.org/drawingml/2006/main">
               <a:ext uri="{FF2B5EF4-FFF2-40B4-BE49-F238E27FC236}">
-                <a16:creationId xmlns:a16="http://schemas.microsoft.com/office/drawing/2014/main" id="{0C333CA6-1E13-42A0-8C1C-F56FD2658C0F}"/>
+                <a16:creationId xmlns:a16="http://schemas.microsoft.com/office/drawing/2014/main" id="{2A76256F-5A8C-4014-8241-C646D40451A8}"/>
               </a:ext>
             </a:extLst>
           </p:cNvPr>
@@ -8761,7 +8963,7 @@
           <p:cNvPr id="2" name="">
             <a:extLst xmlns:a="http://schemas.openxmlformats.org/drawingml/2006/main">
               <a:ext uri="{FF2B5EF4-FFF2-40B4-BE49-F238E27FC236}">
-                <a16:creationId xmlns:a16="http://schemas.microsoft.com/office/drawing/2014/main" id="{F6911C71-5272-456B-8D4F-3E4AA58813B2}"/>
+                <a16:creationId xmlns:a16="http://schemas.microsoft.com/office/drawing/2014/main" id="{9F866C34-E866-44CC-83AC-079E7426F969}"/>
               </a:ext>
             </a:extLst>
           </p:cNvPr>
@@ -9183,7 +9385,7 @@
           <p:cNvPr id="3" name="">
             <a:extLst xmlns:a="http://schemas.openxmlformats.org/drawingml/2006/main">
               <a:ext uri="{FF2B5EF4-FFF2-40B4-BE49-F238E27FC236}">
-                <a16:creationId xmlns:a16="http://schemas.microsoft.com/office/drawing/2014/main" id="{C59E02A5-7DF8-49CA-A8C0-0108BA91BC08}"/>
+                <a16:creationId xmlns:a16="http://schemas.microsoft.com/office/drawing/2014/main" id="{30999B5E-553F-4805-8BA6-33B834285D9E}"/>
               </a:ext>
             </a:extLst>
           </p:cNvPr>
@@ -9337,7 +9539,7 @@
     </p:spTree>
     <p:extLst>
       <p:ext uri="{BB962C8B-B14F-4D97-AF65-F5344CB8AC3E}">
-        <p14:creationId xmlns:p14="http://schemas.microsoft.com/office/powerpoint/2010/main" val="55291284"/>
+        <p14:creationId xmlns:p14="http://schemas.microsoft.com/office/powerpoint/2010/main" val="1243262184"/>
       </p:ext>
     </p:extLst>
   </p:cSld>
@@ -9368,7 +9570,7 @@
           <p:cNvPr id="4" name="">
             <a:extLst xmlns:a="http://schemas.openxmlformats.org/drawingml/2006/main">
               <a:ext uri="{FF2B5EF4-FFF2-40B4-BE49-F238E27FC236}">
-                <a16:creationId xmlns:a16="http://schemas.microsoft.com/office/drawing/2014/main" id="{F09F5805-2495-4241-8CC0-5BA3FC00C5BA}"/>
+                <a16:creationId xmlns:a16="http://schemas.microsoft.com/office/drawing/2014/main" id="{16DAC0E9-43BF-44CE-9F8C-5254E5D9D140}"/>
               </a:ext>
             </a:extLst>
           </p:cNvPr>
@@ -9524,7 +9726,7 @@
           <p:cNvPr id="2" name="Chart">
             <a:extLst xmlns:a="http://schemas.openxmlformats.org/drawingml/2006/main">
               <a:ext uri="{FF2B5EF4-FFF2-40B4-BE49-F238E27FC236}">
-                <a16:creationId xmlns:a16="http://schemas.microsoft.com/office/drawing/2014/main" id="{0D430A06-E0A9-436E-A425-AEC2F62773CD}"/>
+                <a16:creationId xmlns:a16="http://schemas.microsoft.com/office/drawing/2014/main" id="{4867732C-4EE1-4A5B-9251-491BF327BBBC}"/>
               </a:ext>
             </a:extLst>
           </p:cNvPr>
@@ -9537,7 +9739,7 @@
         </p:xfrm>
         <a:graphic xmlns:a="http://schemas.openxmlformats.org/drawingml/2006/main">
           <a:graphicData uri="http://schemas.openxmlformats.org/drawingml/2006/chart">
-            <c:chart xmlns:r="http://schemas.openxmlformats.org/officeDocument/2006/relationships" xmlns:c="http://schemas.openxmlformats.org/drawingml/2006/chart" r:id="R9780d586ec554f35"/>
+            <c:chart xmlns:r="http://schemas.openxmlformats.org/officeDocument/2006/relationships" xmlns:c="http://schemas.openxmlformats.org/drawingml/2006/chart" r:id="R68b9a5f69cfb4a3c"/>
           </a:graphicData>
         </a:graphic>
       </p:graphicFrame>
@@ -9546,7 +9748,7 @@
           <p:cNvPr id="3" name="">
             <a:extLst xmlns:a="http://schemas.openxmlformats.org/drawingml/2006/main">
               <a:ext uri="{FF2B5EF4-FFF2-40B4-BE49-F238E27FC236}">
-                <a16:creationId xmlns:a16="http://schemas.microsoft.com/office/drawing/2014/main" id="{0BF316AA-7308-4FA5-9073-E4B276DA8B7B}"/>
+                <a16:creationId xmlns:a16="http://schemas.microsoft.com/office/drawing/2014/main" id="{27821C7A-69E4-407E-8E89-191E707DC400}"/>
               </a:ext>
             </a:extLst>
           </p:cNvPr>
@@ -9723,7 +9925,7 @@
     </p:spTree>
     <p:extLst>
       <p:ext uri="{BB962C8B-B14F-4D97-AF65-F5344CB8AC3E}">
-        <p14:creationId xmlns:p14="http://schemas.microsoft.com/office/powerpoint/2010/main" val="567691008"/>
+        <p14:creationId xmlns:p14="http://schemas.microsoft.com/office/powerpoint/2010/main" val="1433051826"/>
       </p:ext>
     </p:extLst>
   </p:cSld>
@@ -9754,7 +9956,7 @@
           <p:cNvPr id="6" name="">
             <a:extLst xmlns:a="http://schemas.openxmlformats.org/drawingml/2006/main">
               <a:ext uri="{FF2B5EF4-FFF2-40B4-BE49-F238E27FC236}">
-                <a16:creationId xmlns:a16="http://schemas.microsoft.com/office/drawing/2014/main" id="{E4E795A9-02E0-4958-8DC1-0723F31B17E3}"/>
+                <a16:creationId xmlns:a16="http://schemas.microsoft.com/office/drawing/2014/main" id="{149A4AB3-10D8-4AE8-8D52-A9A9F08970AC}"/>
               </a:ext>
             </a:extLst>
           </p:cNvPr>
@@ -9910,7 +10112,7 @@
           <p:cNvPr id="2" name="">
             <a:extLst xmlns:a="http://schemas.openxmlformats.org/drawingml/2006/main">
               <a:ext uri="{FF2B5EF4-FFF2-40B4-BE49-F238E27FC236}">
-                <a16:creationId xmlns:a16="http://schemas.microsoft.com/office/drawing/2014/main" id="{3A45915D-61FA-43C0-A7B5-87E36C680446}"/>
+                <a16:creationId xmlns:a16="http://schemas.microsoft.com/office/drawing/2014/main" id="{C91DB747-A6A5-438F-9E04-B97A9F7346B4}"/>
               </a:ext>
             </a:extLst>
           </p:cNvPr>
@@ -10066,7 +10268,7 @@
           <p:cNvPr id="3" name="">
             <a:extLst xmlns:a="http://schemas.openxmlformats.org/drawingml/2006/main">
               <a:ext uri="{FF2B5EF4-FFF2-40B4-BE49-F238E27FC236}">
-                <a16:creationId xmlns:a16="http://schemas.microsoft.com/office/drawing/2014/main" id="{597A78BC-DBA5-420A-890C-7E2985DB6FB3}"/>
+                <a16:creationId xmlns:a16="http://schemas.microsoft.com/office/drawing/2014/main" id="{31512562-9768-451B-9611-FAA12E1CD13B}"/>
               </a:ext>
             </a:extLst>
           </p:cNvPr>
@@ -10222,7 +10424,7 @@
           <p:cNvPr id="4" name="">
             <a:extLst xmlns:a="http://schemas.openxmlformats.org/drawingml/2006/main">
               <a:ext uri="{FF2B5EF4-FFF2-40B4-BE49-F238E27FC236}">
-                <a16:creationId xmlns:a16="http://schemas.microsoft.com/office/drawing/2014/main" id="{93CE3990-5CD9-4E2C-BF75-04D3CCD5FC6B}"/>
+                <a16:creationId xmlns:a16="http://schemas.microsoft.com/office/drawing/2014/main" id="{7A326F07-D5A8-4136-B072-4CB2142C9B33}"/>
               </a:ext>
             </a:extLst>
           </p:cNvPr>
@@ -10378,7 +10580,7 @@
           <p:cNvPr id="5" name="">
             <a:extLst xmlns:a="http://schemas.openxmlformats.org/drawingml/2006/main">
               <a:ext uri="{FF2B5EF4-FFF2-40B4-BE49-F238E27FC236}">
-                <a16:creationId xmlns:a16="http://schemas.microsoft.com/office/drawing/2014/main" id="{E7AE2783-A937-4BED-9557-95A49FF5EC02}"/>
+                <a16:creationId xmlns:a16="http://schemas.microsoft.com/office/drawing/2014/main" id="{49400399-501B-4CC9-85EB-9B04A6E52E6F}"/>
               </a:ext>
             </a:extLst>
           </p:cNvPr>
@@ -10532,7 +10734,7 @@
     </p:spTree>
     <p:extLst>
       <p:ext uri="{BB962C8B-B14F-4D97-AF65-F5344CB8AC3E}">
-        <p14:creationId xmlns:p14="http://schemas.microsoft.com/office/powerpoint/2010/main" val="1191180488"/>
+        <p14:creationId xmlns:p14="http://schemas.microsoft.com/office/powerpoint/2010/main" val="1098302"/>
       </p:ext>
     </p:extLst>
   </p:cSld>

</xml_diff>